<commit_message>
Embed recap excerpt in slide 11; scripted speaker-script build
Slide 11 now plays a 42 s excerpt (chapter 5 + its clip) inside the
slide show, so one PowerPoint "Record Slide Show" captures the whole
explanation video. Speaker_Script.docx is generated by
docs/make_speaker_script.py and includes recording/export steps.

Co-Authored-By: Claude Opus 5.5 <noreply@anthropic.com>
</commit_message>
<xml_diff>
--- a/docs/Movie_Recap_Presentation.pptx
+++ b/docs/Movie_Recap_Presentation.pptx
@@ -121,14 +121,14 @@
   <p:extLst>
     <p:ext uri="{521415D9-36F7-43E2-AB2F-B90AF26B5E84}">
       <p14:sectionLst xmlns:p14="http://schemas.microsoft.com/office/powerpoint/2010/main">
-        <p14:section name="Introduction" id="{24ff2db1-4f4f-62b8-b772-648e2a4e9c92}">
+        <p14:section name="Introduction" id="{d727529c-7a29-f968-e7cf-5b5d3ac178a4}">
           <p14:sldIdLst>
             <p14:sldId id="256"/>
             <p14:sldId id="257"/>
             <p14:sldId id="258"/>
           </p14:sldIdLst>
         </p14:section>
-        <p14:section name="Solution" id="{9d494c10-0784-765a-d458-764f1fae36d4}">
+        <p14:section name="Solution" id="{b3a6925e-f5b8-0104-99a7-24e253500be9}">
           <p14:sldIdLst>
             <p14:sldId id="259"/>
             <p14:sldId id="260"/>
@@ -136,14 +136,14 @@
             <p14:sldId id="262"/>
           </p14:sldIdLst>
         </p14:section>
-        <p14:section name="Method" id="{317f4948-5965-802d-c4e4-02589bd8f6b9}">
+        <p14:section name="Method" id="{fa1f29ed-276b-20c0-693a-a3b87ed27e7e}">
           <p14:sldIdLst>
             <p14:sldId id="263"/>
             <p14:sldId id="264"/>
             <p14:sldId id="265"/>
           </p14:sldIdLst>
         </p14:section>
-        <p14:section name="Results" id="{121831be-e0a3-97a8-d225-5ebaf06dea64}">
+        <p14:section name="Results" id="{0bd751e5-9c0e-06ab-e926-7aaac3a26f3a}">
           <p14:sldIdLst>
             <p14:sldId id="266"/>
             <p14:sldId id="267"/>
@@ -151,7 +151,7 @@
             <p14:sldId id="269"/>
           </p14:sldIdLst>
         </p14:section>
-        <p14:section name="Conclusion" id="{1b5d66b8-f29e-cc16-03fc-e2ad906872ae}">
+        <p14:section name="Conclusion" id="{200a2b0c-5dac-ce8b-f271-da4675d2b076}">
           <p14:sldIdLst>
             <p14:sldId id="270"/>
           </p14:sldIdLst>
@@ -2013,7 +2013,7 @@
           <a:p>
             <a:r>
               <a:rPr lang="en-US" dirty="0"/>
-              <a:t>And this is the output. The recap is eight minutes fifty-one seconds long, so it is under the ten-minute limit, and it compresses the film by a factor of about seven and a half. About six and a half minutes are original footage. Before each clip, a chapter card reads out the story sentence, using offline text-to-speech that is loudness-matched to the old soundtrack. During each clip you can see the original timecode, the peak number, a bar along the bottom showing where in the film the clip comes from, and a white flash at the exact peak moment. So the link between the summary, the peak point, the time index and the segment is visible on screen. I will now play a short part of the recap.</a:t>
+              <a:t>And this is the output. The recap is eight minutes fifty-one seconds long, so it is under the ten-minute limit, and it compresses the film by a factor of about seven and a half. About six and a half minutes are original footage. Before each clip, a chapter card reads out the story sentence, using offline text-to-speech that is loudness-matched to the old soundtrack. During each clip you can see the original timecode, the peak number, a bar along the bottom showing where in the film the clip comes from, and a white flash at the exact peak moment. So the link between the summary, the peak point, the time index and the segment is visible on screen. Let me play the excerpt on this slide: it is chapter five, the card about Haskell's body, followed by its clip from minute twenty-four. [Click the video and let it play for about forty seconds.]</a:t>
             </a:r>
             <a:endParaRPr lang="en-US" dirty="0"/>
           </a:p>
@@ -5146,14 +5146,23 @@
       </p:pic>
       <p:pic>
         <p:nvPicPr>
-          <p:cNvPr id="5" name="Image 1" descr="Recap clip with original timecode and peak badges">    </p:cNvPr>
+          <p:cNvPr id="4" name="Media 0">
+            <a:hlinkClick r:id="" action="ppaction://media"/>
+          </p:cNvPr>
           <p:cNvPicPr>
             <a:picLocks noChangeAspect="1"/>
           </p:cNvPicPr>
-          <p:nvPr/>
+          <p:nvPr>
+            <a:videoFile r:link="rId2"/>
+            <p:extLst>
+              <p:ext uri="{DAA4B4D4-6D71-4841-9C94-3DE7FCFB9230}">
+                <p14:media xmlns:p14="http://schemas.microsoft.com/office/powerpoint/2010/main" r:embed="rId3"/>
+              </p:ext>
+            </p:extLst>
+          </p:nvPr>
         </p:nvPicPr>
         <p:blipFill>
-          <a:blip r:embed="rId2"/>
+          <a:blip r:embed="rId4"/>
           <a:stretch>
             <a:fillRect/>
           </a:stretch>
@@ -5234,7 +5243,7 @@
                   <a:schemeClr val="accent5"/>
                 </a:solidFill>
               </a:rPr>
-              <a:t>Clip with original timecode, peak badge, film-position bar</a:t>
+              <a:t>▶ Click to play: 42 s excerpt (chapter 5 + its clip)</a:t>
             </a:r>
             <a:endParaRPr lang="en-US" sz="1100" dirty="0"/>
           </a:p>

</xml_diff>